<commit_message>
Rebuild presentation from current pipeline outputs
</commit_message>
<xml_diff>
--- a/outputs/presentation.pptx
+++ b/outputs/presentation.pptx
@@ -3113,7 +3113,7 @@
           <a:lstStyle/>
           <a:p>
             <a:r>
-              <a:t>Trishuli Flood Mapping — 2026</a:t>
+              <a:t>Trishuli / Bhote Koshi flood: Sentinel-1 analysis</a:t>
             </a:r>
           </a:p>
         </p:txBody>
@@ -3133,18 +3133,27 @@
           <a:bodyPr/>
           <a:lstStyle/>
           <a:p>
-            <a:r>
-              <a:t>Sentinel-1 SAR + Machine Learning</a:t>
-            </a:r>
-          </a:p>
-          <a:p>
-            <a:r>
-              <a:t>P1 · P2 · P3 · P4</a:t>
-            </a:r>
-          </a:p>
-          <a:p>
-            <a:r>
-              <a:t>2026-10-01</a:t>
+            <a:pPr>
+              <a:defRPr sz="2200"/>
+            </a:pPr>
+            <a:r>
+              <a:t>Calibrated, terrain-corrected SAR and OpenStreetMap exposure</a:t>
+            </a:r>
+          </a:p>
+          <a:p>
+            <a:pPr>
+              <a:defRPr sz="2200"/>
+            </a:pPr>
+            <a:r>
+              <a:t>Preliminary and unvalidated</a:t>
+            </a:r>
+          </a:p>
+          <a:p>
+            <a:pPr>
+              <a:defRPr sz="2200"/>
+            </a:pPr>
+            <a:r>
+              <a:t>2026-10-04</a:t>
             </a:r>
           </a:p>
         </p:txBody>
@@ -3183,7 +3192,7 @@
           <a:lstStyle/>
           <a:p>
             <a:r>
-              <a:t>Limitations &amp; Next Steps</a:t>
+              <a:t>Limitations and next steps</a:t>
             </a:r>
           </a:p>
         </p:txBody>
@@ -3203,18 +3212,35 @@
           <a:bodyPr/>
           <a:lstStyle/>
           <a:p>
-            <a:r>
-              <a:t>• Single-event training</a:t>
-            </a:r>
-          </a:p>
-          <a:p>
-            <a:r>
-              <a:t>• 30 m misses sub-pixel urban flooding</a:t>
-            </a:r>
-          </a:p>
-          <a:p>
-            <a:r>
-              <a:t>• Next: dual-orbit fusion, S2 validation</a:t>
+            <a:pPr>
+              <a:defRPr sz="2200"/>
+            </a:pPr>
+            <a:r>
+              <a:t>• Post scene is two days after the event</a:t>
+            </a:r>
+          </a:p>
+          <a:p>
+            <a:pPr>
+              <a:defRPr sz="2200"/>
+            </a:pPr>
+            <a:r>
+              <a:t>• 30 m pixels, steep terrain masked, OSM incomplete in rural Rasuwa</a:t>
+            </a:r>
+          </a:p>
+          <a:p>
+            <a:pPr>
+              <a:defRPr sz="2200"/>
+            </a:pPr>
+            <a:r>
+              <a:t>• Next: Sentinel-2, PlanetScope or high-resolution SAR within 24-72 h</a:t>
+            </a:r>
+          </a:p>
+          <a:p>
+            <a:pPr>
+              <a:defRPr sz="2200"/>
+            </a:pPr>
+            <a:r>
+              <a:t>• Replace the threshold detector before reuse</a:t>
             </a:r>
           </a:p>
         </p:txBody>
@@ -3273,18 +3299,27 @@
           <a:bodyPr/>
           <a:lstStyle/>
           <a:p>
-            <a:r>
-              <a:t>• Trishuli / Bhote Koshi corridor flooding</a:t>
-            </a:r>
-          </a:p>
-          <a:p>
-            <a:r>
-              <a:t>• Need rapid extent + impact mapping</a:t>
-            </a:r>
-          </a:p>
-          <a:p>
-            <a:r>
-              <a:t>• 48-hour SAR-to-decision pipeline</a:t>
+            <a:pPr>
+              <a:defRPr sz="2200"/>
+            </a:pPr>
+            <a:r>
+              <a:t>• Suspected GLOF on 2026-08-26, Rasuwa District, Nepal</a:t>
+            </a:r>
+          </a:p>
+          <a:p>
+            <a:pPr>
+              <a:defRPr sz="2200"/>
+            </a:pPr>
+            <a:r>
+              <a:t>• Can free Sentinel-1 data map flood extent and impact quickly?</a:t>
+            </a:r>
+          </a:p>
+          <a:p>
+            <a:pPr>
+              <a:defRPr sz="2200"/>
+            </a:pPr>
+            <a:r>
+              <a:t>• EMSR927 mapped damaged structures but has no flood-extent layer</a:t>
             </a:r>
           </a:p>
         </p:txBody>
@@ -3343,18 +3378,35 @@
           <a:bodyPr/>
           <a:lstStyle/>
           <a:p>
-            <a:r>
-              <a:t>• Sentinel-1 GRD (VV/VH) — 30 m</a:t>
-            </a:r>
-          </a:p>
-          <a:p>
-            <a:r>
-              <a:t>• Copernicus DEM — 30 m</a:t>
-            </a:r>
-          </a:p>
-          <a:p>
-            <a:r>
-              <a:t>• OpenStreetMap buildings &amp; roads</a:t>
+            <a:pPr>
+              <a:defRPr sz="2200"/>
+            </a:pPr>
+            <a:r>
+              <a:t>• Sentinel-1 GRD VV/VH: 2026-08-16 (pre), 2026-08-28 (post)</a:t>
+            </a:r>
+          </a:p>
+          <a:p>
+            <a:pPr>
+              <a:defRPr sz="2200"/>
+            </a:pPr>
+            <a:r>
+              <a:t>• Copernicus GLO-30 DEM</a:t>
+            </a:r>
+          </a:p>
+          <a:p>
+            <a:pPr>
+              <a:defRPr sz="2200"/>
+            </a:pPr>
+            <a:r>
+              <a:t>• OpenStreetMap snapshot of 2026-07-27 (pre-event)</a:t>
+            </a:r>
+          </a:p>
+          <a:p>
+            <a:pPr>
+              <a:defRPr sz="2200"/>
+            </a:pPr>
+            <a:r>
+              <a:t>• EMSR927 damage points, used only for validation</a:t>
             </a:r>
           </a:p>
         </p:txBody>
@@ -3413,23 +3465,35 @@
           <a:bodyPr/>
           <a:lstStyle/>
           <a:p>
-            <a:r>
-              <a:t>1. Align DEM + S1 to 30 m UTM grid</a:t>
-            </a:r>
-          </a:p>
-          <a:p>
-            <a:r>
-              <a:t>2. Detect flood: Δ VV &lt; -1.5 dB</a:t>
-            </a:r>
-          </a:p>
-          <a:p>
-            <a:r>
-              <a:t>3. Train XGBoost on 9 features</a:t>
-            </a:r>
-          </a:p>
-          <a:p>
-            <a:r>
-              <a:t>4. Overlay on OSM for impact</a:t>
+            <a:pPr>
+              <a:defRPr sz="2200"/>
+            </a:pPr>
+            <a:r>
+              <a:t>1. SNAP: orbit file, noise removal, sigma0, terrain correction</a:t>
+            </a:r>
+          </a:p>
+          <a:p>
+            <a:pPr>
+              <a:defRPr sz="2200"/>
+            </a:pPr>
+            <a:r>
+              <a:t>2. Average to a 30 m grid (UTM 45N)</a:t>
+            </a:r>
+          </a:p>
+          <a:p>
+            <a:pPr>
+              <a:defRPr sz="2200"/>
+            </a:pPr>
+            <a:r>
+              <a:t>3. Detect: mean VV/VH change below a threshold, flat land only</a:t>
+            </a:r>
+          </a:p>
+          <a:p>
+            <a:pPr>
+              <a:defRPr sz="2200"/>
+            </a:pPr>
+            <a:r>
+              <a:t>4. Overlay on OSM and validate against EMSR927</a:t>
             </a:r>
           </a:p>
         </p:txBody>
@@ -3468,7 +3532,7 @@
           <a:lstStyle/>
           <a:p>
             <a:r>
-              <a:t>Flood Detection (P2)</a:t>
+              <a:t>Key finding</a:t>
             </a:r>
           </a:p>
         </p:txBody>
@@ -3488,18 +3552,27 @@
           <a:bodyPr/>
           <a:lstStyle/>
           <a:p>
-            <a:r>
-              <a:t>• 22.66 km² observed flooded</a:t>
-            </a:r>
-          </a:p>
-          <a:p>
-            <a:r>
-              <a:t>• Threshold -1.5 dB (clamped Otsu)</a:t>
-            </a:r>
-          </a:p>
-          <a:p>
-            <a:r>
-              <a:t>• Slope &amp; permanent water masked</a:t>
+            <a:pPr>
+              <a:defRPr sz="2200"/>
+            </a:pPr>
+            <a:r>
+              <a:t>• No detectable flood signal on this Sentinel-1 pair</a:t>
+            </a:r>
+          </a:p>
+          <a:p>
+            <a:pPr>
+              <a:defRPr sz="2200"/>
+            </a:pPr>
+            <a:r>
+              <a:t>• River VV change in the Rasuwa reach is no darker than shifted controls</a:t>
+            </a:r>
+          </a:p>
+          <a:p>
+            <a:pPr>
+              <a:defRPr sz="2200"/>
+            </a:pPr>
+            <a:r>
+              <a:t>• The pair cannot resolve the event; it does not show that no flood occurred</a:t>
             </a:r>
           </a:p>
         </p:txBody>
@@ -3538,7 +3611,7 @@
           <a:lstStyle/>
           <a:p>
             <a:r>
-              <a:t>Susceptibility Model (P3)</a:t>
+              <a:t>Detector mask (unvalidated)</a:t>
             </a:r>
           </a:p>
         </p:txBody>
@@ -3558,18 +3631,27 @@
           <a:bodyPr/>
           <a:lstStyle/>
           <a:p>
-            <a:r>
-              <a:t>• XGBoost, 9 features</a:t>
-            </a:r>
-          </a:p>
-          <a:p>
-            <a:r>
-              <a:t>• AUC 0.998</a:t>
-            </a:r>
-          </a:p>
-          <a:p>
-            <a:r>
-              <a:t>• Predicted 23.11 km² — 1.02× observed</a:t>
+            <a:pPr>
+              <a:defRPr sz="2200"/>
+            </a:pPr>
+            <a:r>
+              <a:t>• 5,802 px (5.22 km²), scattered</a:t>
+            </a:r>
+          </a:p>
+          <a:p>
+            <a:pPr>
+              <a:defRPr sz="2200"/>
+            </a:pPr>
+            <a:r>
+              <a:t>• Threshold clipped to -3.5 to -1.5 dB, slope under 12°, patches of 20+ px</a:t>
+            </a:r>
+          </a:p>
+          <a:p>
+            <a:pPr>
+              <a:defRPr sz="2200"/>
+            </a:pPr>
+            <a:r>
+              <a:t>• Selected from noise-level change, so not a flood extent</a:t>
             </a:r>
           </a:p>
         </p:txBody>
@@ -3608,7 +3690,7 @@
           <a:lstStyle/>
           <a:p>
             <a:r>
-              <a:t>Validation</a:t>
+              <a:t>Exposure to the mask</a:t>
             </a:r>
           </a:p>
         </p:txBody>
@@ -3628,18 +3710,35 @@
           <a:bodyPr/>
           <a:lstStyle/>
           <a:p>
-            <a:r>
-              <a:t>• F1 ~0.91</a:t>
-            </a:r>
-          </a:p>
-          <a:p>
-            <a:r>
-              <a:t>• IoU ~0.84</a:t>
-            </a:r>
-          </a:p>
-          <a:p>
-            <a:r>
-              <a:t>• 90%+ of observed flood captured</a:t>
+            <a:pPr>
+              <a:defRPr sz="2200"/>
+            </a:pPr>
+            <a:r>
+              <a:t>• Buildings: 991 of 189,503 (+102 debris-affected)</a:t>
+            </a:r>
+          </a:p>
+          <a:p>
+            <a:pPr>
+              <a:defRPr sz="2200"/>
+            </a:pPr>
+            <a:r>
+              <a:t>• Road segments: 83 of 14,151</a:t>
+            </a:r>
+          </a:p>
+          <a:p>
+            <a:pPr>
+              <a:defRPr sz="2200"/>
+            </a:pPr>
+            <a:r>
+              <a:t>• Bridges: 21 of 385</a:t>
+            </a:r>
+          </a:p>
+          <a:p>
+            <a:pPr>
+              <a:defRPr sz="2200"/>
+            </a:pPr>
+            <a:r>
+              <a:t>• Settlements cut off: 4 of 446</a:t>
             </a:r>
           </a:p>
         </p:txBody>
@@ -3678,7 +3777,7 @@
           <a:lstStyle/>
           <a:p>
             <a:r>
-              <a:t>Impact (P1)</a:t>
+              <a:t>Validation</a:t>
             </a:r>
           </a:p>
         </p:txBody>
@@ -3698,18 +3797,27 @@
           <a:bodyPr/>
           <a:lstStyle/>
           <a:p>
-            <a:r>
-              <a:t>• Buildings flooded: &lt;FILL IN&gt;</a:t>
-            </a:r>
-          </a:p>
-          <a:p>
-            <a:r>
-              <a:t>• Road segments affected: &lt;FILL IN&gt;</a:t>
-            </a:r>
-          </a:p>
-          <a:p>
-            <a:r>
-              <a:t>• Cut-off settlements: &lt;FILL IN&gt;</a:t>
+            <a:pPr>
+              <a:defRPr sz="2200"/>
+            </a:pPr>
+            <a:r>
+              <a:t>• Mask hit rate on EMSR927 damage points vs a random-mask null</a:t>
+            </a:r>
+          </a:p>
+          <a:p>
+            <a:pPr>
+              <a:defRPr sz="2200"/>
+            </a:pPr>
+            <a:r>
+              <a:t>• No mask pixels in 2 of 4 AOIs: a coverage limit, not a detection error</a:t>
+            </a:r>
+          </a:p>
+          <a:p>
+            <a:pPr>
+              <a:defRPr sz="2200"/>
+            </a:pPr>
+            <a:r>
+              <a:t>• U-Net (Sen1Floods11) cannot separate the two scenes, so it is not independent evidence</a:t>
             </a:r>
           </a:p>
         </p:txBody>
@@ -3768,23 +3876,35 @@
           <a:bodyPr/>
           <a:lstStyle/>
           <a:p>
-            <a:r>
-              <a:t>• flood_dashboard_full.html</a:t>
-            </a:r>
-          </a:p>
-          <a:p>
-            <a:r>
-              <a:t>• flood_model.joblib</a:t>
-            </a:r>
-          </a:p>
-          <a:p>
-            <a:r>
-              <a:t>• FINAL_REPORT.pdf</a:t>
-            </a:r>
-          </a:p>
-          <a:p>
-            <a:r>
-              <a:t>• Reproducible pipeline on GitHub</a:t>
+            <a:pPr>
+              <a:defRPr sz="2200"/>
+            </a:pPr>
+            <a:r>
+              <a:t>• Interactive dashboard (outputs/dashboard.html)</a:t>
+            </a:r>
+          </a:p>
+          <a:p>
+            <a:pPr>
+              <a:defRPr sz="2200"/>
+            </a:pPr>
+            <a:r>
+              <a:t>• Situation report and final report</a:t>
+            </a:r>
+          </a:p>
+          <a:p>
+            <a:pPr>
+              <a:defRPr sz="2200"/>
+            </a:pPr>
+            <a:r>
+              <a:t>• Reproducible pipeline (run_all.sh)</a:t>
+            </a:r>
+          </a:p>
+          <a:p>
+            <a:pPr>
+              <a:defRPr sz="2200"/>
+            </a:pPr>
+            <a:r>
+              <a:t>• Trained U-Net weights (flood_unet.pt)</a:t>
             </a:r>
           </a:p>
         </p:txBody>

</xml_diff>

<commit_message>
Step 4 docs: README and report for the null-calibrated detector
</commit_message>
<xml_diff>
--- a/outputs/presentation.pptx
+++ b/outputs/presentation.pptx
@@ -3635,7 +3635,7 @@
               <a:defRPr sz="2200"/>
             </a:pPr>
             <a:r>
-              <a:t>• 5,802 px (5.22 km²), scattered</a:t>
+              <a:t>• 340 px (0.31 km²), scattered</a:t>
             </a:r>
           </a:p>
           <a:p>
@@ -3714,7 +3714,7 @@
               <a:defRPr sz="2200"/>
             </a:pPr>
             <a:r>
-              <a:t>• Buildings: 991 of 189,503 (+102 debris-affected)</a:t>
+              <a:t>• Buildings: 3 of 189,503 (+473 debris-affected)</a:t>
             </a:r>
           </a:p>
           <a:p>
@@ -3722,7 +3722,7 @@
               <a:defRPr sz="2200"/>
             </a:pPr>
             <a:r>
-              <a:t>• Road segments: 83 of 14,151</a:t>
+              <a:t>• Road segments: 0 of 14,151</a:t>
             </a:r>
           </a:p>
           <a:p>
@@ -3730,7 +3730,7 @@
               <a:defRPr sz="2200"/>
             </a:pPr>
             <a:r>
-              <a:t>• Bridges: 21 of 385</a:t>
+              <a:t>• Bridges: 0 of 385</a:t>
             </a:r>
           </a:p>
           <a:p>
@@ -3738,7 +3738,7 @@
               <a:defRPr sz="2200"/>
             </a:pPr>
             <a:r>
-              <a:t>• Settlements cut off: 4 of 446</a:t>
+              <a:t>• Settlements cut off: 0 of 446</a:t>
             </a:r>
           </a:p>
         </p:txBody>

</xml_diff>

<commit_message>
Step 11 evidence: SNAP clean-clone timings (1578 s, cached S1) and detect JSON, git grep, slides
</commit_message>
<xml_diff>
--- a/outputs/presentation.pptx
+++ b/outputs/presentation.pptx
@@ -14,7 +14,6 @@
     <p:sldId id="262" r:id="rId13"/>
     <p:sldId id="263" r:id="rId14"/>
     <p:sldId id="264" r:id="rId15"/>
-    <p:sldId id="265" r:id="rId16"/>
   </p:sldIdLst>
   <p:sldSz cx="9144000" cy="6858000" type="screen4x3"/>
   <p:notesSz cx="6858000" cy="9144000"/>
@@ -3113,7 +3112,7 @@
           <a:lstStyle/>
           <a:p>
             <a:r>
-              <a:t>Trishuli / Bhote Koshi flood: Sentinel-1 analysis</a:t>
+              <a:t>Trishuli / Bhote Koshi flood, 2026-08-26: Sentinel-1 analysis</a:t>
             </a:r>
           </a:p>
         </p:txBody>
@@ -3137,7 +3136,7 @@
               <a:defRPr sz="2200"/>
             </a:pPr>
             <a:r>
-              <a:t>Calibrated, terrain-corrected SAR and OpenStreetMap exposure</a:t>
+              <a:t>Calibrated SAR change detection and OpenStreetMap exposure</a:t>
             </a:r>
           </a:p>
           <a:p>
@@ -3145,7 +3144,7 @@
               <a:defRPr sz="2200"/>
             </a:pPr>
             <a:r>
-              <a:t>Preliminary and unvalidated</a:t>
+              <a:t>Educational prototype, not an operational tool</a:t>
             </a:r>
           </a:p>
           <a:p>
@@ -3153,94 +3152,7 @@
               <a:defRPr sz="2200"/>
             </a:pPr>
             <a:r>
-              <a:t>2026-10-04</a:t>
-            </a:r>
-          </a:p>
-        </p:txBody>
-      </p:sp>
-    </p:spTree>
-  </p:cSld>
-  <p:clrMapOvr>
-    <a:masterClrMapping/>
-  </p:clrMapOvr>
-</p:sld>
-</file>
-
-<file path=ppt/slides/slide10.xml><?xml version="1.0" encoding="utf-8"?>
-<p:sld xmlns:a="http://schemas.openxmlformats.org/drawingml/2006/main" xmlns:p="http://schemas.openxmlformats.org/presentationml/2006/main" xmlns:r="http://schemas.openxmlformats.org/officeDocument/2006/relationships">
-  <p:cSld>
-    <p:spTree>
-      <p:nvGrpSpPr>
-        <p:cNvPr id="1" name=""/>
-        <p:cNvGrpSpPr/>
-        <p:nvPr/>
-      </p:nvGrpSpPr>
-      <p:grpSpPr/>
-      <p:sp>
-        <p:nvSpPr>
-          <p:cNvPr id="2" name="Title 1"/>
-          <p:cNvSpPr>
-            <a:spLocks noGrp="1"/>
-          </p:cNvSpPr>
-          <p:nvPr>
-            <p:ph type="title"/>
-          </p:nvPr>
-        </p:nvSpPr>
-        <p:spPr/>
-        <p:txBody>
-          <a:bodyPr/>
-          <a:lstStyle/>
-          <a:p>
-            <a:r>
-              <a:t>Limitations and next steps</a:t>
-            </a:r>
-          </a:p>
-        </p:txBody>
-      </p:sp>
-      <p:sp>
-        <p:nvSpPr>
-          <p:cNvPr id="3" name="Content Placeholder 2"/>
-          <p:cNvSpPr>
-            <a:spLocks noGrp="1"/>
-          </p:cNvSpPr>
-          <p:nvPr>
-            <p:ph idx="1"/>
-          </p:nvPr>
-        </p:nvSpPr>
-        <p:spPr/>
-        <p:txBody>
-          <a:bodyPr/>
-          <a:lstStyle/>
-          <a:p>
-            <a:pPr>
-              <a:defRPr sz="2200"/>
-            </a:pPr>
-            <a:r>
-              <a:t>• Post scene is two days after the event</a:t>
-            </a:r>
-          </a:p>
-          <a:p>
-            <a:pPr>
-              <a:defRPr sz="2200"/>
-            </a:pPr>
-            <a:r>
-              <a:t>• 30 m pixels, steep terrain masked, OSM incomplete in rural Rasuwa</a:t>
-            </a:r>
-          </a:p>
-          <a:p>
-            <a:pPr>
-              <a:defRPr sz="2200"/>
-            </a:pPr>
-            <a:r>
-              <a:t>• Next: Sentinel-2, PlanetScope or high-resolution SAR within 24-72 h</a:t>
-            </a:r>
-          </a:p>
-          <a:p>
-            <a:pPr>
-              <a:defRPr sz="2200"/>
-            </a:pPr>
-            <a:r>
-              <a:t>• Replace the threshold detector before reuse</a:t>
+              <a:t>2026-10-11</a:t>
             </a:r>
           </a:p>
         </p:txBody>
@@ -3303,7 +3215,7 @@
               <a:defRPr sz="2200"/>
             </a:pPr>
             <a:r>
-              <a:t>• Suspected GLOF on 2026-08-26, Rasuwa District, Nepal</a:t>
+              <a:t>• Event date 2026-08-26, Trishuli / Bhote Koshi, Rasuwa, Nepal</a:t>
             </a:r>
           </a:p>
           <a:p>
@@ -3311,7 +3223,7 @@
               <a:defRPr sz="2200"/>
             </a:pPr>
             <a:r>
-              <a:t>• Can free Sentinel-1 data map flood extent and impact quickly?</a:t>
+              <a:t>• Can free Sentinel-1 data show where the valley floor changed, and what is exposed?</a:t>
             </a:r>
           </a:p>
           <a:p>
@@ -3319,7 +3231,7 @@
               <a:defRPr sz="2200"/>
             </a:pPr>
             <a:r>
-              <a:t>• EMSR927 mapped damaged structures but has no flood-extent layer</a:t>
+              <a:t>• Checking only: Copernicus EMS products (EMSR927 GRA: landslide polygons and damage points, no flood-extent layer)</a:t>
             </a:r>
           </a:p>
         </p:txBody>
@@ -3382,7 +3294,7 @@
               <a:defRPr sz="2200"/>
             </a:pPr>
             <a:r>
-              <a:t>• Sentinel-1 GRD VV/VH: 2026-08-16 (pre), 2026-08-28 (post)</a:t>
+              <a:t>• Sentinel-1 GRD VV/VH, track asc85: references 2026-08-16, 2026-08-04, 2026-07-23, 2026-07-11; post 2026-08-28</a:t>
             </a:r>
           </a:p>
           <a:p>
@@ -3390,7 +3302,7 @@
               <a:defRPr sz="2200"/>
             </a:pPr>
             <a:r>
-              <a:t>• Copernicus GLO-30 DEM</a:t>
+              <a:t>• Copernicus GLO-30 DEM (HAND valley floor, radar layover / shadow mask)</a:t>
             </a:r>
           </a:p>
           <a:p>
@@ -3406,7 +3318,7 @@
               <a:defRPr sz="2200"/>
             </a:pPr>
             <a:r>
-              <a:t>• EMSR927 damage points, used only for validation</a:t>
+              <a:t>• EMS products used only for checking</a:t>
             </a:r>
           </a:p>
         </p:txBody>
@@ -3469,7 +3381,7 @@
               <a:defRPr sz="2200"/>
             </a:pPr>
             <a:r>
-              <a:t>1. SNAP: orbit file, noise removal, sigma0, terrain correction</a:t>
+              <a:t>1. SNAP: orbit file, noise removal, sigma0, terrain correction; 30 m grid</a:t>
             </a:r>
           </a:p>
           <a:p>
@@ -3477,7 +3389,7 @@
               <a:defRPr sz="2200"/>
             </a:pPr>
             <a:r>
-              <a:t>2. Average to a 30 m grid (UTM 45N)</a:t>
+              <a:t>2. Robust-z change of the post scene against 4 pre-event references, valley floor only</a:t>
             </a:r>
           </a:p>
           <a:p>
@@ -3485,7 +3397,7 @@
               <a:defRPr sz="2200"/>
             </a:pPr>
             <a:r>
-              <a:t>3. Detect: mean VV/VH change below a threshold, flat land only</a:t>
+              <a:t>3. Thresholds from leave-one-out null runs on pre-event dates (no EMS)</a:t>
             </a:r>
           </a:p>
           <a:p>
@@ -3493,7 +3405,7 @@
               <a:defRPr sz="2200"/>
             </a:pPr>
             <a:r>
-              <a:t>4. Overlay on OSM and validate against EMSR927</a:t>
+              <a:t>4. Overlay on pre-event OSM: exposure, bridges exposed, hospital access</a:t>
             </a:r>
           </a:p>
         </p:txBody>
@@ -3553,26 +3465,34 @@
           <a:lstStyle/>
           <a:p>
             <a:pPr>
-              <a:defRPr sz="2200"/>
+              <a:defRPr sz="1600"/>
             </a:pPr>
             <a:r>
-              <a:t>• No detectable flood signal on this Sentinel-1 pair</a:t>
+              <a:t>• Detector status: change_detected (calibrated = True)</a:t>
             </a:r>
           </a:p>
           <a:p>
             <a:pPr>
-              <a:defRPr sz="2200"/>
+              <a:defRPr sz="1600"/>
             </a:pPr>
             <a:r>
-              <a:t>• River VV change in the Rasuwa reach is no darker than shifted controls</a:t>
+              <a:t>• Flagged: 0.31 km² flood-like (water-like backscatter change), 2.29 km² dark, 0.54 km² bright</a:t>
             </a:r>
           </a:p>
           <a:p>
             <a:pPr>
-              <a:defRPr sz="2200"/>
+              <a:defRPr sz="1600"/>
             </a:pPr>
             <a:r>
-              <a:t>• The pair cannot resolve the event; it does not show that no flood occurred</a:t>
+              <a:t>• Flood-like change (0.31 km² of water-like backscatter change) and surface change (2.29 km² dark, 0.54 km² bright) are each separable from all four pre-event nulls. An independent single-date water model could not separate the event from pre-event dates, and Sentinel-2 does not confirm open water.</a:t>
+            </a:r>
+          </a:p>
+          <a:p>
+            <a:pPr>
+              <a:defRPr sz="1600"/>
+            </a:pPr>
+            <a:r>
+              <a:t>• Surface change on the valley floor, not a validated flood extent</a:t>
             </a:r>
           </a:p>
         </p:txBody>
@@ -3611,7 +3531,7 @@
           <a:lstStyle/>
           <a:p>
             <a:r>
-              <a:t>Detector mask (unvalidated)</a:t>
+              <a:t>Exposure to the mask (not damage)</a:t>
             </a:r>
           </a:p>
         </p:txBody>
@@ -3632,26 +3552,34 @@
           <a:lstStyle/>
           <a:p>
             <a:pPr>
-              <a:defRPr sz="2200"/>
+              <a:defRPr sz="1800"/>
             </a:pPr>
             <a:r>
-              <a:t>• 340 px (0.31 km²), scattered</a:t>
+              <a:t>• Buildings overlapping the mask: 556 (range 244-1,078) of 189,503; 92% unknown status</a:t>
             </a:r>
           </a:p>
           <a:p>
             <a:pPr>
-              <a:defRPr sz="2200"/>
+              <a:defRPr sz="1800"/>
             </a:pPr>
             <a:r>
-              <a:t>• Threshold clipped to -3.5 to -1.5 dB, slope under 12°, patches of 20+ px</a:t>
+              <a:t>• Motorable road in mask: 11.8 km (range 6.4-22.0)</a:t>
             </a:r>
           </a:p>
           <a:p>
             <a:pPr>
-              <a:defRPr sz="2200"/>
+              <a:defRPr sz="1800"/>
             </a:pPr>
             <a:r>
-              <a:t>• Selected from noise-level change, so not a flood extent</a:t>
+              <a:t>• Bridges exposed (not failed): 20 (range 12-30)</a:t>
+            </a:r>
+          </a:p>
+          <a:p>
+            <a:pPr>
+              <a:defRPr sz="1800"/>
+            </a:pPr>
+            <a:r>
+              <a:t>• Settlements with no road path to a hospital: 4 (range 2-12) of 446</a:t>
             </a:r>
           </a:p>
         </p:txBody>
@@ -3690,7 +3618,7 @@
           <a:lstStyle/>
           <a:p>
             <a:r>
-              <a:t>Exposure to the mask</a:t>
+              <a:t>Validation</a:t>
             </a:r>
           </a:p>
         </p:txBody>
@@ -3711,34 +3639,42 @@
           <a:lstStyle/>
           <a:p>
             <a:pPr>
-              <a:defRPr sz="2200"/>
+              <a:defRPr sz="1800"/>
             </a:pPr>
             <a:r>
-              <a:t>• Buildings: 3 of 189,503 (+473 debris-affected)</a:t>
+              <a:t>• Check-only reference: EMSR927 landslide polygons and damage points (GRA products)</a:t>
             </a:r>
           </a:p>
           <a:p>
             <a:pPr>
-              <a:defRPr sz="2200"/>
+              <a:defRPr sz="1800"/>
             </a:pPr>
             <a:r>
-              <a:t>• Road segments: 0 of 14,151</a:t>
+              <a:t>• Hold-out AOI03 vs landslide polygons: precision 0.93, recall 0.17, IoU 0.17</a:t>
             </a:r>
           </a:p>
           <a:p>
             <a:pPr>
-              <a:defRPr sz="2200"/>
+              <a:defRPr sz="1800"/>
             </a:pPr>
             <a:r>
-              <a:t>• Bridges: 0 of 385</a:t>
+              <a:t>• Damage-point recall at 0 m: 23% [11%-33%], indistinguishable from chance</a:t>
             </a:r>
           </a:p>
           <a:p>
             <a:pPr>
-              <a:defRPr sz="2200"/>
+              <a:defRPr sz="1800"/>
             </a:pPr>
             <a:r>
-              <a:t>• Settlements cut off: 0 of 446</a:t>
+              <a:t>• No flood-extent layer: the flood class is not validated against EMS</a:t>
+            </a:r>
+          </a:p>
+          <a:p>
+            <a:pPr>
+              <a:defRPr sz="1800"/>
+            </a:pPr>
+            <a:r>
+              <a:t>• Water model on the corridor (prediction-only): not separable from the nulls, so it is not independent evidence</a:t>
             </a:r>
           </a:p>
         </p:txBody>
@@ -3777,7 +3713,7 @@
           <a:lstStyle/>
           <a:p>
             <a:r>
-              <a:t>Validation</a:t>
+              <a:t>Deliverables</a:t>
             </a:r>
           </a:p>
         </p:txBody>
@@ -3801,7 +3737,7 @@
               <a:defRPr sz="2200"/>
             </a:pPr>
             <a:r>
-              <a:t>• Mask hit rate on EMSR927 damage points vs a random-mask null</a:t>
+              <a:t>• Interactive dashboard (outputs/dashboard/index.html, works offline)</a:t>
             </a:r>
           </a:p>
           <a:p>
@@ -3809,7 +3745,7 @@
               <a:defRPr sz="2200"/>
             </a:pPr>
             <a:r>
-              <a:t>• No mask pixels in 2 of 4 AOIs: a coverage limit, not a detection error</a:t>
+              <a:t>• Situation reports (EN, NE, one page) and docs/REPORT.pdf</a:t>
             </a:r>
           </a:p>
           <a:p>
@@ -3817,7 +3753,15 @@
               <a:defRPr sz="2200"/>
             </a:pPr>
             <a:r>
-              <a:t>• U-Net (Sen1Floods11) cannot separate the two scenes, so it is not independent evidence</a:t>
+              <a:t>• Reproducible pipeline: python -m src.run (SNAP route; --s1-source pc cross-check)</a:t>
+            </a:r>
+          </a:p>
+          <a:p>
+            <a:pPr>
+              <a:defRPr sz="2200"/>
+            </a:pPr>
+            <a:r>
+              <a:t>• Water-model weights (models/)</a:t>
             </a:r>
           </a:p>
         </p:txBody>
@@ -3856,7 +3800,7 @@
           <a:lstStyle/>
           <a:p>
             <a:r>
-              <a:t>Deliverables</a:t>
+              <a:t>Limitations and next steps</a:t>
             </a:r>
           </a:p>
         </p:txBody>
@@ -3880,7 +3824,7 @@
               <a:defRPr sz="2200"/>
             </a:pPr>
             <a:r>
-              <a:t>• Interactive dashboard (outputs/dashboard.html)</a:t>
+              <a:t>• One track; post scene 2026-08-28</a:t>
             </a:r>
           </a:p>
           <a:p>
@@ -3888,7 +3832,7 @@
               <a:defRPr sz="2200"/>
             </a:pPr>
             <a:r>
-              <a:t>• Situation report and final report</a:t>
+              <a:t>• 30 m pixels, steep terrain masked, OSM incomplete in rural areas</a:t>
             </a:r>
           </a:p>
           <a:p>
@@ -3896,15 +3840,7 @@
               <a:defRPr sz="2200"/>
             </a:pPr>
             <a:r>
-              <a:t>• Reproducible pipeline (run_all.sh)</a:t>
-            </a:r>
-          </a:p>
-          <a:p>
-            <a:pPr>
-              <a:defRPr sz="2200"/>
-            </a:pPr>
-            <a:r>
-              <a:t>• Trained U-Net weights (flood_unet.pt)</a:t>
+              <a:t>• Next: a second track or a closer post scene, post-event OSM for cut-off checks</a:t>
             </a:r>
           </a:p>
         </p:txBody>

</xml_diff>